<commit_message>
Strengthen problem statement across README and pitch deck
</commit_message>
<xml_diff>
--- a/pitch/ArchGuard-Pitch.pptx
+++ b/pitch/ArchGuard-Pitch.pptx
@@ -3318,8 +3318,42 @@
         </p:nvSpPr>
         <p:spPr>
           <a:xfrm>
-            <a:off x="731520" y="1463040"/>
-            <a:ext cx="10698480" cy="4572000"/>
+            <a:off x="274320" y="1051560"/>
+            <a:ext cx="11612880" cy="457200"/>
+          </a:xfrm>
+          <a:prstGeom prst="rect">
+            <a:avLst/>
+          </a:prstGeom>
+          <a:noFill/>
+        </p:spPr>
+        <p:txBody>
+          <a:bodyPr wrap="square" anchor="t">
+            <a:spAutoFit/>
+          </a:bodyPr>
+          <a:lstStyle/>
+          <a:p>
+            <a:pPr algn="l"/>
+            <a:r>
+              <a:rPr sz="1600" b="1">
+                <a:solidFill>
+                  <a:srgbClr val="444444"/>
+                </a:solidFill>
+              </a:rPr>
+              <a:t>Architecture review is a point-in-time event, not a continuous practice</a:t>
+            </a:r>
+          </a:p>
+        </p:txBody>
+      </p:sp>
+      <p:sp>
+        <p:nvSpPr>
+          <p:cNvPr id="4" name="TextBox 3"/>
+          <p:cNvSpPr txBox="1"/>
+          <p:nvPr/>
+        </p:nvSpPr>
+        <p:spPr>
+          <a:xfrm>
+            <a:off x="731520" y="1737360"/>
+            <a:ext cx="10698480" cy="3840480"/>
           </a:xfrm>
           <a:prstGeom prst="rect">
             <a:avLst/>
@@ -3338,12 +3372,12 @@
               </a:spcAft>
             </a:pPr>
             <a:r>
-              <a:rPr sz="2200">
+              <a:rPr sz="2000">
                 <a:solidFill>
                   <a:srgbClr val="444444"/>
                 </a:solidFill>
               </a:rPr>
-              <a:t>• Architecture is reviewed once at an ARB, then drifts silently.</a:t>
+              <a:t>• Reviewed once, then it drifts — signed off at kickoff, maybe revisited at an ARB every ~6 months; code drifts in between until it is expensive to unwind.</a:t>
             </a:r>
           </a:p>
           <a:p>
@@ -3353,12 +3387,12 @@
               </a:spcAft>
             </a:pPr>
             <a:r>
-              <a:rPr sz="2200">
+              <a:rPr sz="2000">
                 <a:solidFill>
                   <a:srgbClr val="444444"/>
                 </a:solidFill>
               </a:rPr>
-              <a:t>• Rules live in Confluence and people's heads — not enforced in code.</a:t>
+              <a:t>• Rules are hard to enforce because they are hard to update — they live in wikis, slides, and senior engineers' heads, so they go stale and get ignored.</a:t>
             </a:r>
           </a:p>
           <a:p>
@@ -3368,41 +3402,26 @@
               </a:spcAft>
             </a:pPr>
             <a:r>
-              <a:rPr sz="2200">
+              <a:rPr sz="2000">
                 <a:solidFill>
                   <a:srgbClr val="444444"/>
                 </a:solidFill>
               </a:rPr>
-              <a:t>• By the time drift is found, it is expensive to unwind.</a:t>
-            </a:r>
-          </a:p>
-          <a:p>
-            <a:pPr>
-              <a:spcAft>
-                <a:spcPts val="800"/>
-              </a:spcAft>
-            </a:pPr>
-            <a:r>
-              <a:rPr sz="2200">
-                <a:solidFill>
-                  <a:srgbClr val="444444"/>
-                </a:solidFill>
-              </a:rPr>
-              <a:t>• Generic AI PR reviewers are non-deterministic and cannot gate a merge.</a:t>
-            </a:r>
-          </a:p>
-        </p:txBody>
-      </p:sp>
-      <p:sp>
-        <p:nvSpPr>
-          <p:cNvPr id="4" name="TextBox 3"/>
+              <a:t>• Developers can't follow what they can't see — guidance is verbal and tribal, never expressed as architecture-as-code, so there is no check on the PR.</a:t>
+            </a:r>
+          </a:p>
+        </p:txBody>
+      </p:sp>
+      <p:sp>
+        <p:nvSpPr>
+          <p:cNvPr id="5" name="TextBox 4"/>
           <p:cNvSpPr txBox="1"/>
           <p:nvPr/>
         </p:nvSpPr>
         <p:spPr>
           <a:xfrm>
-            <a:off x="731520" y="5486400"/>
-            <a:ext cx="10698480" cy="731520"/>
+            <a:off x="731520" y="5669280"/>
+            <a:ext cx="10698480" cy="822960"/>
           </a:xfrm>
           <a:prstGeom prst="rect">
             <a:avLst/>
@@ -3417,12 +3436,12 @@
           <a:p>
             <a:pPr algn="l"/>
             <a:r>
-              <a:rPr sz="2000" b="1">
+              <a:rPr sz="1800" b="1">
                 <a:solidFill>
                   <a:srgbClr val="1F4E79"/>
                 </a:solidFill>
               </a:rPr>
-              <a:t>“We review architecture at the start, then hope. Drift is discovered late.”</a:t>
+              <a:t>Architecture intent is never turned into an executable, always-on check that runs where developers work — the pull request.</a:t>
             </a:r>
           </a:p>
         </p:txBody>

</xml_diff>

<commit_message>
Add two-sided problem framing + fresh use-case research (idea 10); simplify to Define/Automate/Enforce
</commit_message>
<xml_diff>
--- a/pitch/ArchGuard-Pitch.pptx
+++ b/pitch/ArchGuard-Pitch.pptx
@@ -3339,7 +3339,7 @@
                   <a:srgbClr val="444444"/>
                 </a:solidFill>
               </a:rPr>
-              <a:t>Architecture review is a point-in-time event, not a continuous practice</a:t>
+              <a:t>A two-sided pain — for the developer and the architect</a:t>
             </a:r>
           </a:p>
         </p:txBody>
@@ -3352,8 +3352,8 @@
         </p:nvSpPr>
         <p:spPr>
           <a:xfrm>
-            <a:off x="731520" y="1737360"/>
-            <a:ext cx="10698480" cy="3840480"/>
+            <a:off x="731520" y="1554480"/>
+            <a:ext cx="10698480" cy="4023360"/>
           </a:xfrm>
           <a:prstGeom prst="rect">
             <a:avLst/>
@@ -3372,12 +3372,12 @@
               </a:spcAft>
             </a:pPr>
             <a:r>
-              <a:rPr sz="2000">
+              <a:rPr sz="1800">
                 <a:solidFill>
                   <a:srgbClr val="444444"/>
                 </a:solidFill>
               </a:rPr>
-              <a:t>• Reviewed once, then it drifts — signed off at kickoff, maybe revisited at an ARB every ~6 months; code drifts in between until it is expensive to unwind.</a:t>
+              <a:t>• Developers must ship fast but don't hold the whole architecture in their head — so they cross a boundary without knowing it existed.</a:t>
             </a:r>
           </a:p>
           <a:p>
@@ -3387,12 +3387,12 @@
               </a:spcAft>
             </a:pPr>
             <a:r>
-              <a:rPr sz="2000">
+              <a:rPr sz="1800">
                 <a:solidFill>
                   <a:srgbClr val="444444"/>
                 </a:solidFill>
               </a:rPr>
-              <a:t>• Rules are hard to enforce because they are hard to update — they live in wikis, slides, and senior engineers' heads, so they go stale and get ignored.</a:t>
+              <a:t>• Architects have no lever except email — nudging teams rule by rule, thread by thread. Governance by reminder doesn't scale.</a:t>
             </a:r>
           </a:p>
           <a:p>
@@ -3402,12 +3402,27 @@
               </a:spcAft>
             </a:pPr>
             <a:r>
-              <a:rPr sz="2000">
+              <a:rPr sz="1800">
                 <a:solidFill>
                   <a:srgbClr val="444444"/>
                 </a:solidFill>
               </a:rPr>
-              <a:t>• Developers can't follow what they can't see — guidance is verbal and tribal, never expressed as architecture-as-code, so there is no check on the PR.</a:t>
+              <a:t>• Reviewed once, then it drifts — signed off at kickoff, maybe revisited at an ARB every ~6 months; code drifts in between until it is expensive to unwind.</a:t>
+            </a:r>
+          </a:p>
+          <a:p>
+            <a:pPr>
+              <a:spcAft>
+                <a:spcPts val="800"/>
+              </a:spcAft>
+            </a:pPr>
+            <a:r>
+              <a:rPr sz="1800">
+                <a:solidFill>
+                  <a:srgbClr val="444444"/>
+                </a:solidFill>
+              </a:rPr>
+              <a:t>• Rules are hard to enforce because they are hard to update — they live in wikis, slides, and heads, never as architecture-as-code, so there is no check on the PR.</a:t>
             </a:r>
           </a:p>
         </p:txBody>
@@ -3420,8 +3435,8 @@
         </p:nvSpPr>
         <p:spPr>
           <a:xfrm>
-            <a:off x="731520" y="5669280"/>
-            <a:ext cx="10698480" cy="822960"/>
+            <a:off x="731520" y="5760720"/>
+            <a:ext cx="10698480" cy="731520"/>
           </a:xfrm>
           <a:prstGeom prst="rect">
             <a:avLst/>
@@ -3436,7 +3451,7 @@
           <a:p>
             <a:pPr algn="l"/>
             <a:r>
-              <a:rPr sz="1800" b="1">
+              <a:rPr sz="1700" b="1">
                 <a:solidFill>
                   <a:srgbClr val="1F4E79"/>
                 </a:solidFill>
@@ -3510,7 +3525,7 @@
                   <a:srgbClr val="FFFFFF"/>
                 </a:solidFill>
               </a:rPr>
-              <a:t>   The idea</a:t>
+              <a:t>   The idea — Define, Automate, Enforce</a:t>
             </a:r>
           </a:p>
         </p:txBody>
@@ -3523,8 +3538,8 @@
         </p:nvSpPr>
         <p:spPr>
           <a:xfrm>
-            <a:off x="731520" y="1463040"/>
-            <a:ext cx="10698480" cy="4114800"/>
+            <a:off x="731520" y="1554480"/>
+            <a:ext cx="10698480" cy="3840480"/>
           </a:xfrm>
           <a:prstGeom prst="rect">
             <a:avLst/>
@@ -3543,12 +3558,12 @@
               </a:spcAft>
             </a:pPr>
             <a:r>
-              <a:rPr sz="2200">
+              <a:rPr sz="2100">
                 <a:solidFill>
                   <a:srgbClr val="444444"/>
                 </a:solidFill>
               </a:rPr>
-              <a:t>• Architects write rules in plain English (org / domain / team / service, HLD + LLD).</a:t>
+              <a:t>• Define — write the rule in plain English. No DSL, no special syntax; easy for any architect.</a:t>
             </a:r>
           </a:p>
           <a:p>
@@ -3558,12 +3573,12 @@
               </a:spcAft>
             </a:pPr>
             <a:r>
-              <a:rPr sz="2200">
+              <a:rPr sz="2100">
                 <a:solidFill>
                   <a:srgbClr val="444444"/>
                 </a:solidFill>
               </a:rPr>
-              <a:t>• An LLM compiles each rule into architecture-as-code — once, at authoring time.</a:t>
+              <a:t>• Automate — an LLM turns it into an architectural fitness function (architecture-as-code), once, at authoring time.</a:t>
             </a:r>
           </a:p>
           <a:p>
@@ -3573,12 +3588,12 @@
               </a:spcAft>
             </a:pPr>
             <a:r>
-              <a:rPr sz="2200">
+              <a:rPr sz="2100">
                 <a:solidFill>
                   <a:srgbClr val="444444"/>
                 </a:solidFill>
               </a:rPr>
-              <a:t>• The pipeline runs the compiled rules deterministically on every PR.</a:t>
+              <a:t>• Enforce — the pipeline runs that fitness function deterministically on every PR.</a:t>
             </a:r>
           </a:p>
           <a:p>
@@ -3588,7 +3603,7 @@
               </a:spcAft>
             </a:pPr>
             <a:r>
-              <a:rPr sz="2200">
+              <a:rPr sz="2100">
                 <a:solidFill>
                   <a:srgbClr val="444444"/>
                 </a:solidFill>
@@ -3606,7 +3621,7 @@
         </p:nvSpPr>
         <p:spPr>
           <a:xfrm>
-            <a:off x="731520" y="5577840"/>
+            <a:off x="731520" y="5669280"/>
             <a:ext cx="10698480" cy="731520"/>
           </a:xfrm>
           <a:prstGeom prst="rect">
@@ -3627,7 +3642,7 @@
                   <a:srgbClr val="2E7D32"/>
                 </a:solidFill>
               </a:rPr>
-              <a:t>The model proposes at authoring time. The compiled rule decides at runtime.</a:t>
+              <a:t>The model proposes at authoring time. The fitness function decides at runtime.</a:t>
             </a:r>
           </a:p>
         </p:txBody>

</xml_diff>